<commit_message>
fix(modelos): formatar mes do certificado por extenso
</commit_message>
<xml_diff>
--- a/cursos/Rapel.pptx
+++ b/cursos/Rapel.pptx
@@ -3546,8 +3546,8 @@
         </p:nvGrpSpPr>
         <p:grpSpPr>
           <a:xfrm>
-            <a:off x="8793777" y="5035384"/>
-            <a:ext cx="2520269" cy="1014730"/>
+            <a:off x="8347075" y="5035550"/>
+            <a:ext cx="2797810" cy="1014730"/>
             <a:chOff x="8345848" y="5079429"/>
             <a:chExt cx="2520269" cy="1014730"/>
           </a:xfrm>
@@ -3670,7 +3670,7 @@
           </p:nvSpPr>
           <p:spPr>
             <a:xfrm>
-              <a:off x="8750403" y="5259329"/>
+              <a:off x="8542192" y="5266949"/>
               <a:ext cx="2088000" cy="36000"/>
             </a:xfrm>
             <a:prstGeom prst="rect">

</xml_diff>